<commit_message>
Cite holdouts, staff accounts and the altitude scale in the executive deck.
The interview slides were still saying staff, prospects and validation were pending after those results landed.

Co-authored-by: Cursor <cursoragent@cursor.com>
</commit_message>
<xml_diff>
--- a/demo/deck/stuffplus2240.pptx
+++ b/demo/deck/stuffplus2240.pptx
@@ -586,12 +586,12 @@
           <a:lstStyle/>
           <a:p>
             <a:r>
-              <a:t>70 s. Abrir comparación por forma, mostrar la pérdida del arsenal y discutir el pitch que más contribuye. Si dashboard no está integrado o falla, usar las tablas y estas láminas. Terminar con el siguiente paso: validar, confirmar el staff y contrastar recomendaciones con el coach. No afirmar demo en vivo verificada.</a:t>
-            </a:r>
-          </a:p>
-          <a:p>
-            <a:r>
-              <a:t>Fuentes: Respaldo: reports/altitude_delta/ y reports/pitcher_sensitivity/. Integración de dashboard pendiente.</a:t>
+              <a:t>70 s. Abrir el simulador con una forma y dos densidades. Pasar al leaderboard anónimo y al mapa de altitud. Si la red o el deploy fallan, quedarse en este PDF y en los CSV agregados. Cerrar confirmando que las franquicias 5 y 11 no se suman y que la sede no está confirmada.</a:t>
+            </a:r>
+          </a:p>
+          <a:p>
+            <a:r>
+              <a:t>Fuentes: Dashboard en el repo. Respaldo: reports/altitude_delta/ y este PDF.</a:t>
             </a:r>
           </a:p>
         </p:txBody>
@@ -811,12 +811,12 @@
           <a:lstStyle/>
           <a:p>
             <a:r>
-              <a:t>75 s. RMSE menor es mejor. La mejora de Pitching+ no se atribuye a Stuff+ puro. La preparación global es transductiva: faltan holdouts inductivos reales por lanzador, temporada y parque. No usar benchmark/demo como calidad real.</a:t>
-            </a:r>
-          </a:p>
-          <a:p>
-            <a:r>
-              <a:t>Fuentes: reports/stuff_model/metrics.csv; reports/pitching_model/metrics.csv · rv_x, baseline por conteo.</a:t>
+              <a:t>75 s. Skill es la fracción de RMSE que el modelo le quita al baseline por conteo. Pitching+ se mantiene en k-fold de pitcher, holdout de parque y holdout de temporada. Stuff+ no mejora ese baseline. Los rasgos se armaron con toda la muestra: es evidencia exploratoria, no un pronóstico ciego. No citar validation/demo.</a:t>
+            </a:r>
+          </a:p>
+          <a:p>
+            <a:r>
+              <a:t>Fuentes: reports/validation/headline.csv · skill frente al baseline por conteo.</a:t>
             </a:r>
           </a:p>
         </p:txBody>
@@ -1036,12 +1036,12 @@
           <a:lstStyle/>
           <a:p>
             <a:r>
-              <a:t>55 s. Las franquicias 5 y 11 son candidatos por densidad, no identificación verificada de Diablos. La auditoría de uso en casa frente a gira está pendiente. No nombrar una rotación, un bullpen o pitches para cortar sin el vínculo oficial y HACK-032.</a:t>
-            </a:r>
-          </a:p>
-          <a:p>
-            <a:r>
-              <a:t>Fuentes: reports/park_id/franchise_rho.csv; reports/park_id/harp_helu.md · identidad provisional.</a:t>
+              <a:t>55 s. Leer cada franquicia sola. Son los dos candidatos por densidad, no un staff confirmado de Diablos. Las carreras salen del modelo: mezcla de lanzamientos en casa más reasignación de aperturas. No sumar 5 y 11. No nombrar al club hasta que el staff confirme la sede.</a:t>
+            </a:r>
+          </a:p>
+          <a:p>
+            <a:r>
+              <a:t>Fuentes: reports/staff_audit/runs_saved.csv · franquicias 5 y 11, por separado.</a:t>
             </a:r>
           </a:p>
         </p:txBody>
@@ -1111,12 +1111,12 @@
           <a:lstStyle/>
           <a:p>
             <a:r>
-              <a:t>50 s. Solicitar velocidad, giro, eje de giro, punto de liberación y extensión del arsenal. El motor compara movimiento y calidad en dos ambientes. La salida del evaluador de prospectos y sus comparables aún debe integrarse y verificarse. No emitir Firmar o Evitar con evidencia incompleta.</a:t>
-            </a:r>
-          </a:p>
-          <a:p>
-            <a:r>
-              <a:t>Fuentes: Contrato: docs/CONTRACT.md; stuffplus/schema.py. Flujo propuesto, sin evaluación real de prospectos.</a:t>
+              <a:t>50 s. El perfilador toma de 2 a 5 lanzamientos y devuelve Stuff+ neutral y en el Harp Helú, comparables anónimos y un veredicto: Firmar, Desarrollar o Evitar para casa. Esta lámina no evalúa a una persona: muestra la recta de referencia que mejor rankea en ese aire. No pagar por ride de nivel del mar.</a:t>
+            </a:r>
+          </a:p>
+          <a:p>
+            <a:r>
+              <a:t>Fuentes: reports/ideal_profile/best_fastballs.csv · recta de rango 1 por Stuff+ en el Harp Helú.</a:t>
             </a:r>
           </a:p>
         </p:txBody>
@@ -1186,12 +1186,12 @@
           <a:lstStyle/>
           <a:p>
             <a:r>
-              <a:t>65 s. Carreras por victoria como conversión descriptiva: liga y bucket Extreme. El bucket no certifica identidad del estadio. Las conversiones de puntos Stuff+ a carreras dependen de la desviación del xRV predicho y calibración final. Las tablas por calidad del modelo son escenarios, no ahorros observados.</a:t>
-            </a:r>
-          </a:p>
-          <a:p>
-            <a:r>
-              <a:t>Fuentes: reports/business_value/runs_per_win.csv · aproximación pitagórica; no proyección de ahorro del staff.</a:t>
+              <a:t>65 s. Carreras por victoria: liga contra el bucket Extreme. En altura cada carrera vale menos victorias. La escala es carreras por punto de Stuff+ y por lanzamiento, ajustada fuera de muestra. Un salto de muchos puntos en todo el arsenal es un escenario, no el ahorro del staff de la lámina anterior.</a:t>
+            </a:r>
+          </a:p>
+          <a:p>
+            <a:r>
+              <a:t>Fuentes: reports/business_value/runs_per_win.csv; reports/business_value/runs_per_point_direct.csv · Stuff+, rv_x, fuera de muestra.</a:t>
             </a:r>
           </a:p>
         </p:txBody>
@@ -4574,7 +4574,7 @@
               </a:defRPr>
             </a:pPr>
             <a:r>
-              <a:t>Staff, prospectos y validación inductiva siguen pendientes.</a:t>
+              <a:t>La sede del staff sigue sin confirmarse.</a:t>
             </a:r>
           </a:p>
         </p:txBody>
@@ -4722,7 +4722,7 @@
               </a:defRPr>
             </a:pPr>
             <a:r>
-              <a:t>La demo compara y explica el arsenal</a:t>
+              <a:t>La demo compara el mismo arsenal</a:t>
             </a:r>
           </a:p>
         </p:txBody>
@@ -4758,7 +4758,7 @@
               </a:defRPr>
             </a:pPr>
             <a:r>
-              <a:t>Respaldo: reports/altitude_delta/ y reports/pitcher_sensitivity/. Integración de dashboard pendiente.</a:t>
+              <a:t>Dashboard en el repo. Respaldo: reports/altitude_delta/ y este PDF.</a:t>
             </a:r>
           </a:p>
         </p:txBody>
@@ -4830,7 +4830,7 @@
               </a:defRPr>
             </a:pPr>
             <a:r>
-              <a:t>Comparar movimiento entre ambientes.</a:t>
+              <a:t>Simulador: la misma forma, dos aires.</a:t>
             </a:r>
           </a:p>
         </p:txBody>
@@ -4866,7 +4866,7 @@
               </a:defRPr>
             </a:pPr>
             <a:r>
-              <a:t>Revisar qué pitch impulsa la pérdida.</a:t>
+              <a:t>Leaderboard: arsenales anónimos.</a:t>
             </a:r>
           </a:p>
         </p:txBody>
@@ -4902,7 +4902,7 @@
               </a:defRPr>
             </a:pPr>
             <a:r>
-              <a:t>Mostrar cobertura y límites del resultado.</a:t>
+              <a:t>Mapa: dónde se pierde el movimiento.</a:t>
             </a:r>
           </a:p>
         </p:txBody>
@@ -4938,7 +4938,7 @@
               </a:defRPr>
             </a:pPr>
             <a:r>
-              <a:t>Respaldo offline: agregados y PDF de esta presentación.</a:t>
+              <a:t>Respaldo offline: este PDF y los CSV agregados.</a:t>
             </a:r>
           </a:p>
         </p:txBody>
@@ -4974,7 +4974,7 @@
               </a:defRPr>
             </a:pPr>
             <a:r>
-              <a:t>La recomendación final requiere validar y confirmar el staff.</a:t>
+              <a:t>La sede del staff sigue sin confirmarse.</a:t>
             </a:r>
           </a:p>
         </p:txBody>
@@ -6153,7 +6153,7 @@
               </a:defRPr>
             </a:pPr>
             <a:r>
-              <a:t>Pitching+ mejora el error. Stuff+ queda cerca</a:t>
+              <a:t>Pitching+ se sostiene fuera de muestra</a:t>
             </a:r>
           </a:p>
         </p:txBody>
@@ -6189,7 +6189,7 @@
               </a:defRPr>
             </a:pPr>
             <a:r>
-              <a:t>reports/stuff_model/metrics.csv; reports/pitching_model/metrics.csv · rv_x, baseline por conteo.</a:t>
+              <a:t>reports/validation/headline.csv · skill frente al baseline por conteo.</a:t>
             </a:r>
           </a:p>
         </p:txBody>
@@ -6261,7 +6261,7 @@
               </a:defRPr>
             </a:pPr>
             <a:r>
-              <a:t>Baseline</a:t>
+              <a:t>Pitcher</a:t>
             </a:r>
           </a:p>
         </p:txBody>
@@ -6275,108 +6275,7 @@
         <p:spPr>
           <a:xfrm>
             <a:off x="2730500" y="1854200"/>
-            <a:ext cx="3824408" cy="228600"/>
-          </a:xfrm>
-          <a:prstGeom prst="rect">
-            <a:avLst/>
-          </a:prstGeom>
-          <a:solidFill>
-            <a:srgbClr val="585B60"/>
-          </a:solidFill>
-          <a:ln>
-            <a:noFill/>
-          </a:ln>
-        </p:spPr>
-        <p:txBody>
-          <a:bodyPr rtlCol="0" anchor="ctr"/>
-          <a:lstStyle/>
-          <a:p>
-            <a:pPr algn="ctr"/>
-          </a:p>
-        </p:txBody>
-      </p:sp>
-      <p:sp>
-        <p:nvSpPr>
-          <p:cNvPr id="10" name="TextBox 9"/>
-          <p:cNvSpPr txBox="1"/>
-          <p:nvPr/>
-        </p:nvSpPr>
-        <p:spPr>
-          <a:xfrm>
-            <a:off x="7264400" y="1790700"/>
-            <a:ext cx="1371600" cy="346964"/>
-          </a:xfrm>
-          <a:prstGeom prst="rect">
-            <a:avLst/>
-          </a:prstGeom>
-          <a:noFill/>
-        </p:spPr>
-        <p:txBody>
-          <a:bodyPr wrap="none" lIns="0" rIns="0" tIns="0" bIns="0" anchor="t">
-            <a:spAutoFit/>
-          </a:bodyPr>
-          <a:lstStyle/>
-          <a:p>
-            <a:pPr>
-              <a:defRPr sz="1800" b="1">
-                <a:solidFill>
-                  <a:srgbClr val="202124"/>
-                </a:solidFill>
-                <a:latin typeface="Arial"/>
-              </a:defRPr>
-            </a:pPr>
-            <a:r>
-              <a:t>0.19776</a:t>
-            </a:r>
-          </a:p>
-        </p:txBody>
-      </p:sp>
-      <p:sp>
-        <p:nvSpPr>
-          <p:cNvPr id="11" name="TextBox 10"/>
-          <p:cNvSpPr txBox="1"/>
-          <p:nvPr/>
-        </p:nvSpPr>
-        <p:spPr>
-          <a:xfrm>
-            <a:off x="508000" y="2400300"/>
-            <a:ext cx="1905000" cy="331216"/>
-          </a:xfrm>
-          <a:prstGeom prst="rect">
-            <a:avLst/>
-          </a:prstGeom>
-          <a:noFill/>
-        </p:spPr>
-        <p:txBody>
-          <a:bodyPr wrap="none" lIns="0" rIns="0" tIns="0" bIns="0" anchor="t">
-            <a:spAutoFit/>
-          </a:bodyPr>
-          <a:lstStyle/>
-          <a:p>
-            <a:pPr>
-              <a:defRPr sz="1700" b="0">
-                <a:solidFill>
-                  <a:srgbClr val="202124"/>
-                </a:solidFill>
-                <a:latin typeface="Arial"/>
-              </a:defRPr>
-            </a:pPr>
-            <a:r>
-              <a:t>Stuff+</a:t>
-            </a:r>
-          </a:p>
-        </p:txBody>
-      </p:sp>
-      <p:sp>
-        <p:nvSpPr>
-          <p:cNvPr id="12" name="Rectangle 11"/>
-          <p:cNvSpPr/>
-          <p:nvPr/>
-        </p:nvSpPr>
-        <p:spPr>
-          <a:xfrm>
-            <a:off x="2730500" y="2451100"/>
-            <a:ext cx="3825569" cy="228600"/>
+            <a:ext cx="3301491" cy="228600"/>
           </a:xfrm>
           <a:prstGeom prst="rect">
             <a:avLst/>
@@ -6398,13 +6297,13 @@
       </p:sp>
       <p:sp>
         <p:nvSpPr>
-          <p:cNvPr id="13" name="TextBox 12"/>
-          <p:cNvSpPr txBox="1"/>
-          <p:nvPr/>
-        </p:nvSpPr>
-        <p:spPr>
-          <a:xfrm>
-            <a:off x="7264400" y="2387600"/>
+          <p:cNvPr id="10" name="TextBox 9"/>
+          <p:cNvSpPr txBox="1"/>
+          <p:nvPr/>
+        </p:nvSpPr>
+        <p:spPr>
+          <a:xfrm>
+            <a:off x="7264400" y="1790700"/>
             <a:ext cx="1371600" cy="346964"/>
           </a:xfrm>
           <a:prstGeom prst="rect">
@@ -6427,20 +6326,20 @@
               </a:defRPr>
             </a:pPr>
             <a:r>
-              <a:t>0.19782</a:t>
-            </a:r>
-          </a:p>
-        </p:txBody>
-      </p:sp>
-      <p:sp>
-        <p:nvSpPr>
-          <p:cNvPr id="14" name="TextBox 13"/>
-          <p:cNvSpPr txBox="1"/>
-          <p:nvPr/>
-        </p:nvSpPr>
-        <p:spPr>
-          <a:xfrm>
-            <a:off x="508000" y="2997200"/>
+              <a:t>3.88%</a:t>
+            </a:r>
+          </a:p>
+        </p:txBody>
+      </p:sp>
+      <p:sp>
+        <p:nvSpPr>
+          <p:cNvPr id="11" name="TextBox 10"/>
+          <p:cNvSpPr txBox="1"/>
+          <p:nvPr/>
+        </p:nvSpPr>
+        <p:spPr>
+          <a:xfrm>
+            <a:off x="508000" y="2400300"/>
             <a:ext cx="1905000" cy="331216"/>
           </a:xfrm>
           <a:prstGeom prst="rect">
@@ -6463,27 +6362,27 @@
               </a:defRPr>
             </a:pPr>
             <a:r>
-              <a:t>Pitching+</a:t>
-            </a:r>
-          </a:p>
-        </p:txBody>
-      </p:sp>
-      <p:sp>
-        <p:nvSpPr>
-          <p:cNvPr id="15" name="Rectangle 14"/>
+              <a:t>Parque</a:t>
+            </a:r>
+          </a:p>
+        </p:txBody>
+      </p:sp>
+      <p:sp>
+        <p:nvSpPr>
+          <p:cNvPr id="12" name="Rectangle 11"/>
           <p:cNvSpPr/>
           <p:nvPr/>
         </p:nvSpPr>
         <p:spPr>
           <a:xfrm>
-            <a:off x="2730500" y="3048000"/>
-            <a:ext cx="3676081" cy="228600"/>
+            <a:off x="2730500" y="2451100"/>
+            <a:ext cx="2790951" cy="228600"/>
           </a:xfrm>
           <a:prstGeom prst="rect">
             <a:avLst/>
           </a:prstGeom>
           <a:solidFill>
-            <a:srgbClr val="202124"/>
+            <a:srgbClr val="D71920"/>
           </a:solidFill>
           <a:ln>
             <a:noFill/>
@@ -6499,6 +6398,107 @@
       </p:sp>
       <p:sp>
         <p:nvSpPr>
+          <p:cNvPr id="13" name="TextBox 12"/>
+          <p:cNvSpPr txBox="1"/>
+          <p:nvPr/>
+        </p:nvSpPr>
+        <p:spPr>
+          <a:xfrm>
+            <a:off x="7264400" y="2387600"/>
+            <a:ext cx="1371600" cy="346964"/>
+          </a:xfrm>
+          <a:prstGeom prst="rect">
+            <a:avLst/>
+          </a:prstGeom>
+          <a:noFill/>
+        </p:spPr>
+        <p:txBody>
+          <a:bodyPr wrap="none" lIns="0" rIns="0" tIns="0" bIns="0" anchor="t">
+            <a:spAutoFit/>
+          </a:bodyPr>
+          <a:lstStyle/>
+          <a:p>
+            <a:pPr>
+              <a:defRPr sz="1800" b="1">
+                <a:solidFill>
+                  <a:srgbClr val="202124"/>
+                </a:solidFill>
+                <a:latin typeface="Arial"/>
+              </a:defRPr>
+            </a:pPr>
+            <a:r>
+              <a:t>3.28%</a:t>
+            </a:r>
+          </a:p>
+        </p:txBody>
+      </p:sp>
+      <p:sp>
+        <p:nvSpPr>
+          <p:cNvPr id="14" name="TextBox 13"/>
+          <p:cNvSpPr txBox="1"/>
+          <p:nvPr/>
+        </p:nvSpPr>
+        <p:spPr>
+          <a:xfrm>
+            <a:off x="508000" y="2997200"/>
+            <a:ext cx="1905000" cy="331216"/>
+          </a:xfrm>
+          <a:prstGeom prst="rect">
+            <a:avLst/>
+          </a:prstGeom>
+          <a:noFill/>
+        </p:spPr>
+        <p:txBody>
+          <a:bodyPr wrap="none" lIns="0" rIns="0" tIns="0" bIns="0" anchor="t">
+            <a:spAutoFit/>
+          </a:bodyPr>
+          <a:lstStyle/>
+          <a:p>
+            <a:pPr>
+              <a:defRPr sz="1700" b="0">
+                <a:solidFill>
+                  <a:srgbClr val="202124"/>
+                </a:solidFill>
+                <a:latin typeface="Arial"/>
+              </a:defRPr>
+            </a:pPr>
+            <a:r>
+              <a:t>Temporada</a:t>
+            </a:r>
+          </a:p>
+        </p:txBody>
+      </p:sp>
+      <p:sp>
+        <p:nvSpPr>
+          <p:cNvPr id="15" name="Rectangle 14"/>
+          <p:cNvSpPr/>
+          <p:nvPr/>
+        </p:nvSpPr>
+        <p:spPr>
+          <a:xfrm>
+            <a:off x="2730500" y="3048000"/>
+            <a:ext cx="3182366" cy="228600"/>
+          </a:xfrm>
+          <a:prstGeom prst="rect">
+            <a:avLst/>
+          </a:prstGeom>
+          <a:solidFill>
+            <a:srgbClr val="D71920"/>
+          </a:solidFill>
+          <a:ln>
+            <a:noFill/>
+          </a:ln>
+        </p:spPr>
+        <p:txBody>
+          <a:bodyPr rtlCol="0" anchor="ctr"/>
+          <a:lstStyle/>
+          <a:p>
+            <a:pPr algn="ctr"/>
+          </a:p>
+        </p:txBody>
+      </p:sp>
+      <p:sp>
+        <p:nvSpPr>
           <p:cNvPr id="16" name="TextBox 15"/>
           <p:cNvSpPr txBox="1"/>
           <p:nvPr/>
@@ -6528,7 +6528,7 @@
               </a:defRPr>
             </a:pPr>
             <a:r>
-              <a:t>0.19009</a:t>
+              <a:t>3.74%</a:t>
             </a:r>
           </a:p>
         </p:txBody>
@@ -6542,21 +6542,21 @@
         <p:spPr>
           <a:xfrm>
             <a:off x="508000" y="3708400"/>
-            <a:ext cx="8128000" cy="331216"/>
-          </a:xfrm>
-          <a:prstGeom prst="rect">
-            <a:avLst/>
-          </a:prstGeom>
-          <a:noFill/>
-        </p:spPr>
-        <p:txBody>
-          <a:bodyPr wrap="none" lIns="0" rIns="0" tIns="0" bIns="0" anchor="t">
-            <a:spAutoFit/>
-          </a:bodyPr>
-          <a:lstStyle/>
-          <a:p>
-            <a:pPr>
-              <a:defRPr sz="1700" b="1">
+            <a:ext cx="8128000" cy="299720"/>
+          </a:xfrm>
+          <a:prstGeom prst="rect">
+            <a:avLst/>
+          </a:prstGeom>
+          <a:noFill/>
+        </p:spPr>
+        <p:txBody>
+          <a:bodyPr wrap="none" lIns="0" rIns="0" tIns="0" bIns="0" anchor="t">
+            <a:spAutoFit/>
+          </a:bodyPr>
+          <a:lstStyle/>
+          <a:p>
+            <a:pPr>
+              <a:defRPr sz="1500" b="1">
                 <a:solidFill>
                   <a:srgbClr val="202124"/>
                 </a:solidFill>
@@ -6564,7 +6564,7 @@
               </a:defRPr>
             </a:pPr>
             <a:r>
-              <a:t>Pitching+: 3.88% menos RMSE frente al baseline por conteo.</a:t>
+              <a:t>Pitching+: % de RMSE que baja frente al baseline por conteo.</a:t>
             </a:r>
           </a:p>
         </p:txBody>
@@ -6577,7 +6577,7 @@
         </p:nvSpPr>
         <p:spPr>
           <a:xfrm>
-            <a:off x="508000" y="4102100"/>
+            <a:off x="508000" y="4064000"/>
             <a:ext cx="8128000" cy="283972"/>
           </a:xfrm>
           <a:prstGeom prst="rect">
@@ -6600,7 +6600,7 @@
               </a:defRPr>
             </a:pPr>
             <a:r>
-              <a:t>Preparación global. La validación inductiva sigue pendiente.</a:t>
+              <a:t>Stuff+ en k-fold de pitcher: -0.03%. No mejora ese baseline.</a:t>
             </a:r>
           </a:p>
         </p:txBody>
@@ -7952,7 +7952,7 @@
               </a:defRPr>
             </a:pPr>
             <a:r>
-              <a:t>El staff requiere confirmar la sede</a:t>
+              <a:t>Dos sedes, dos cuentas de carreras</a:t>
             </a:r>
           </a:p>
         </p:txBody>
@@ -7988,7 +7988,7 @@
               </a:defRPr>
             </a:pPr>
             <a:r>
-              <a:t>reports/park_id/franchise_rho.csv; reports/park_id/harp_helu.md · identidad provisional.</a:t>
+              <a:t>reports/staff_audit/runs_saved.csv · franquicias 5 y 11, por separado.</a:t>
             </a:r>
           </a:p>
         </p:txBody>
@@ -8037,22 +8037,94 @@
         </p:nvSpPr>
         <p:spPr>
           <a:xfrm>
-            <a:off x="508000" y="1828800"/>
-            <a:ext cx="3810000" cy="441452"/>
-          </a:xfrm>
-          <a:prstGeom prst="rect">
-            <a:avLst/>
-          </a:prstGeom>
-          <a:noFill/>
-        </p:spPr>
-        <p:txBody>
-          <a:bodyPr wrap="none" lIns="0" rIns="0" tIns="0" bIns="0" anchor="t">
-            <a:spAutoFit/>
-          </a:bodyPr>
-          <a:lstStyle/>
-          <a:p>
-            <a:pPr>
-              <a:defRPr sz="2400" b="1">
+            <a:off x="508000" y="1752600"/>
+            <a:ext cx="3810000" cy="346964"/>
+          </a:xfrm>
+          <a:prstGeom prst="rect">
+            <a:avLst/>
+          </a:prstGeom>
+          <a:noFill/>
+        </p:spPr>
+        <p:txBody>
+          <a:bodyPr wrap="none" lIns="0" rIns="0" tIns="0" bIns="0" anchor="t">
+            <a:spAutoFit/>
+          </a:bodyPr>
+          <a:lstStyle/>
+          <a:p>
+            <a:pPr>
+              <a:defRPr sz="1800" b="1">
+                <a:solidFill>
+                  <a:srgbClr val="D71920"/>
+                </a:solidFill>
+                <a:latin typeface="Arial"/>
+              </a:defRPr>
+            </a:pPr>
+            <a:r>
+              <a:t>Franquicia 5</a:t>
+            </a:r>
+          </a:p>
+        </p:txBody>
+      </p:sp>
+      <p:sp>
+        <p:nvSpPr>
+          <p:cNvPr id="9" name="TextBox 8"/>
+          <p:cNvSpPr txBox="1"/>
+          <p:nvPr/>
+        </p:nvSpPr>
+        <p:spPr>
+          <a:xfrm>
+            <a:off x="508000" y="2108200"/>
+            <a:ext cx="3810000" cy="567436"/>
+          </a:xfrm>
+          <a:prstGeom prst="rect">
+            <a:avLst/>
+          </a:prstGeom>
+          <a:noFill/>
+        </p:spPr>
+        <p:txBody>
+          <a:bodyPr wrap="none" lIns="0" rIns="0" tIns="0" bIns="0" anchor="t">
+            <a:spAutoFit/>
+          </a:bodyPr>
+          <a:lstStyle/>
+          <a:p>
+            <a:pPr>
+              <a:defRPr sz="3200" b="1">
+                <a:solidFill>
+                  <a:srgbClr val="D71920"/>
+                </a:solidFill>
+                <a:latin typeface="Arial"/>
+              </a:defRPr>
+            </a:pPr>
+            <a:r>
+              <a:t>4.37 carreras</a:t>
+            </a:r>
+          </a:p>
+        </p:txBody>
+      </p:sp>
+      <p:sp>
+        <p:nvSpPr>
+          <p:cNvPr id="10" name="TextBox 9"/>
+          <p:cNvSpPr txBox="1"/>
+          <p:nvPr/>
+        </p:nvSpPr>
+        <p:spPr>
+          <a:xfrm>
+            <a:off x="508000" y="2616200"/>
+            <a:ext cx="3810000" cy="315468"/>
+          </a:xfrm>
+          <a:prstGeom prst="rect">
+            <a:avLst/>
+          </a:prstGeom>
+          <a:noFill/>
+        </p:spPr>
+        <p:txBody>
+          <a:bodyPr wrap="none" lIns="0" rIns="0" tIns="0" bIns="0" anchor="t">
+            <a:spAutoFit/>
+          </a:bodyPr>
+          <a:lstStyle/>
+          <a:p>
+            <a:pPr>
+              <a:defRPr sz="1600" b="0">
                 <a:solidFill>
                   <a:srgbClr val="202124"/>
                 </a:solidFill>
@@ -8060,35 +8132,143 @@
               </a:defRPr>
             </a:pPr>
             <a:r>
-              <a:t>Franquicia 5: 0.821</a:t>
-            </a:r>
-          </a:p>
-        </p:txBody>
-      </p:sp>
-      <p:sp>
-        <p:nvSpPr>
-          <p:cNvPr id="9" name="TextBox 8"/>
-          <p:cNvSpPr txBox="1"/>
-          <p:nvPr/>
-        </p:nvSpPr>
-        <p:spPr>
-          <a:xfrm>
-            <a:off x="508000" y="2206752"/>
-            <a:ext cx="3810000" cy="441452"/>
-          </a:xfrm>
-          <a:prstGeom prst="rect">
-            <a:avLst/>
-          </a:prstGeom>
-          <a:noFill/>
-        </p:spPr>
-        <p:txBody>
-          <a:bodyPr wrap="none" lIns="0" rIns="0" tIns="0" bIns="0" anchor="t">
-            <a:spAutoFit/>
-          </a:bodyPr>
-          <a:lstStyle/>
-          <a:p>
-            <a:pPr>
-              <a:defRPr sz="2400" b="1">
+              <a:t>0.30 victorias por temporada</a:t>
+            </a:r>
+          </a:p>
+        </p:txBody>
+      </p:sp>
+      <p:sp>
+        <p:nvSpPr>
+          <p:cNvPr id="11" name="TextBox 10"/>
+          <p:cNvSpPr txBox="1"/>
+          <p:nvPr/>
+        </p:nvSpPr>
+        <p:spPr>
+          <a:xfrm>
+            <a:off x="508000" y="2971800"/>
+            <a:ext cx="3810000" cy="299720"/>
+          </a:xfrm>
+          <a:prstGeom prst="rect">
+            <a:avLst/>
+          </a:prstGeom>
+          <a:noFill/>
+        </p:spPr>
+        <p:txBody>
+          <a:bodyPr wrap="none" lIns="0" rIns="0" tIns="0" bIns="0" anchor="t">
+            <a:spAutoFit/>
+          </a:bodyPr>
+          <a:lstStyle/>
+          <a:p>
+            <a:pPr>
+              <a:defRPr sz="1500" b="0">
+                <a:solidFill>
+                  <a:srgbClr val="585B60"/>
+                </a:solidFill>
+                <a:latin typeface="Arial"/>
+              </a:defRPr>
+            </a:pPr>
+            <a:r>
+              <a:t>Mezcla 3.02 · aperturas 1.35</a:t>
+            </a:r>
+          </a:p>
+        </p:txBody>
+      </p:sp>
+      <p:sp>
+        <p:nvSpPr>
+          <p:cNvPr id="12" name="TextBox 11"/>
+          <p:cNvSpPr txBox="1"/>
+          <p:nvPr/>
+        </p:nvSpPr>
+        <p:spPr>
+          <a:xfrm>
+            <a:off x="4826000" y="1752600"/>
+            <a:ext cx="3810000" cy="346964"/>
+          </a:xfrm>
+          <a:prstGeom prst="rect">
+            <a:avLst/>
+          </a:prstGeom>
+          <a:noFill/>
+        </p:spPr>
+        <p:txBody>
+          <a:bodyPr wrap="none" lIns="0" rIns="0" tIns="0" bIns="0" anchor="t">
+            <a:spAutoFit/>
+          </a:bodyPr>
+          <a:lstStyle/>
+          <a:p>
+            <a:pPr>
+              <a:defRPr sz="1800" b="1">
+                <a:solidFill>
+                  <a:srgbClr val="D71920"/>
+                </a:solidFill>
+                <a:latin typeface="Arial"/>
+              </a:defRPr>
+            </a:pPr>
+            <a:r>
+              <a:t>Franquicia 11</a:t>
+            </a:r>
+          </a:p>
+        </p:txBody>
+      </p:sp>
+      <p:sp>
+        <p:nvSpPr>
+          <p:cNvPr id="13" name="TextBox 12"/>
+          <p:cNvSpPr txBox="1"/>
+          <p:nvPr/>
+        </p:nvSpPr>
+        <p:spPr>
+          <a:xfrm>
+            <a:off x="4826000" y="2108200"/>
+            <a:ext cx="3810000" cy="567436"/>
+          </a:xfrm>
+          <a:prstGeom prst="rect">
+            <a:avLst/>
+          </a:prstGeom>
+          <a:noFill/>
+        </p:spPr>
+        <p:txBody>
+          <a:bodyPr wrap="none" lIns="0" rIns="0" tIns="0" bIns="0" anchor="t">
+            <a:spAutoFit/>
+          </a:bodyPr>
+          <a:lstStyle/>
+          <a:p>
+            <a:pPr>
+              <a:defRPr sz="3200" b="1">
+                <a:solidFill>
+                  <a:srgbClr val="D71920"/>
+                </a:solidFill>
+                <a:latin typeface="Arial"/>
+              </a:defRPr>
+            </a:pPr>
+            <a:r>
+              <a:t>3.22 carreras</a:t>
+            </a:r>
+          </a:p>
+        </p:txBody>
+      </p:sp>
+      <p:sp>
+        <p:nvSpPr>
+          <p:cNvPr id="14" name="TextBox 13"/>
+          <p:cNvSpPr txBox="1"/>
+          <p:nvPr/>
+        </p:nvSpPr>
+        <p:spPr>
+          <a:xfrm>
+            <a:off x="4826000" y="2616200"/>
+            <a:ext cx="3810000" cy="315468"/>
+          </a:xfrm>
+          <a:prstGeom prst="rect">
+            <a:avLst/>
+          </a:prstGeom>
+          <a:noFill/>
+        </p:spPr>
+        <p:txBody>
+          <a:bodyPr wrap="none" lIns="0" rIns="0" tIns="0" bIns="0" anchor="t">
+            <a:spAutoFit/>
+          </a:bodyPr>
+          <a:lstStyle/>
+          <a:p>
+            <a:pPr>
+              <a:defRPr sz="1600" b="0">
                 <a:solidFill>
                   <a:srgbClr val="202124"/>
                 </a:solidFill>
@@ -8096,35 +8276,71 @@
               </a:defRPr>
             </a:pPr>
             <a:r>
-              <a:t>Franquicia 11: 0.813</a:t>
-            </a:r>
-          </a:p>
-        </p:txBody>
-      </p:sp>
-      <p:sp>
-        <p:nvSpPr>
-          <p:cNvPr id="10" name="TextBox 9"/>
-          <p:cNvSpPr txBox="1"/>
-          <p:nvPr/>
-        </p:nvSpPr>
-        <p:spPr>
-          <a:xfrm>
-            <a:off x="508000" y="2997200"/>
-            <a:ext cx="3810000" cy="346964"/>
-          </a:xfrm>
-          <a:prstGeom prst="rect">
-            <a:avLst/>
-          </a:prstGeom>
-          <a:noFill/>
-        </p:spPr>
-        <p:txBody>
-          <a:bodyPr wrap="none" lIns="0" rIns="0" tIns="0" bIns="0" anchor="t">
-            <a:spAutoFit/>
-          </a:bodyPr>
-          <a:lstStyle/>
-          <a:p>
-            <a:pPr>
-              <a:defRPr sz="1800" b="0">
+              <a:t>0.23 victorias por temporada</a:t>
+            </a:r>
+          </a:p>
+        </p:txBody>
+      </p:sp>
+      <p:sp>
+        <p:nvSpPr>
+          <p:cNvPr id="15" name="TextBox 14"/>
+          <p:cNvSpPr txBox="1"/>
+          <p:nvPr/>
+        </p:nvSpPr>
+        <p:spPr>
+          <a:xfrm>
+            <a:off x="4826000" y="2971800"/>
+            <a:ext cx="3810000" cy="299720"/>
+          </a:xfrm>
+          <a:prstGeom prst="rect">
+            <a:avLst/>
+          </a:prstGeom>
+          <a:noFill/>
+        </p:spPr>
+        <p:txBody>
+          <a:bodyPr wrap="none" lIns="0" rIns="0" tIns="0" bIns="0" anchor="t">
+            <a:spAutoFit/>
+          </a:bodyPr>
+          <a:lstStyle/>
+          <a:p>
+            <a:pPr>
+              <a:defRPr sz="1500" b="0">
+                <a:solidFill>
+                  <a:srgbClr val="585B60"/>
+                </a:solidFill>
+                <a:latin typeface="Arial"/>
+              </a:defRPr>
+            </a:pPr>
+            <a:r>
+              <a:t>Mezcla 1.22 · aperturas 2.01</a:t>
+            </a:r>
+          </a:p>
+        </p:txBody>
+      </p:sp>
+      <p:sp>
+        <p:nvSpPr>
+          <p:cNvPr id="16" name="TextBox 15"/>
+          <p:cNvSpPr txBox="1"/>
+          <p:nvPr/>
+        </p:nvSpPr>
+        <p:spPr>
+          <a:xfrm>
+            <a:off x="508000" y="3784600"/>
+            <a:ext cx="8128000" cy="315468"/>
+          </a:xfrm>
+          <a:prstGeom prst="rect">
+            <a:avLst/>
+          </a:prstGeom>
+          <a:noFill/>
+        </p:spPr>
+        <p:txBody>
+          <a:bodyPr wrap="none" lIns="0" rIns="0" tIns="0" bIns="0" anchor="t">
+            <a:spAutoFit/>
+          </a:bodyPr>
+          <a:lstStyle/>
+          <a:p>
+            <a:pPr>
+              <a:defRPr sz="1600" b="0">
                 <a:solidFill>
                   <a:srgbClr val="202124"/>
                 </a:solidFill>
@@ -8132,35 +8348,35 @@
               </a:defRPr>
             </a:pPr>
             <a:r>
-              <a:t>Candidatos por densidad.</a:t>
-            </a:r>
-          </a:p>
-        </p:txBody>
-      </p:sp>
-      <p:sp>
-        <p:nvSpPr>
-          <p:cNvPr id="11" name="TextBox 10"/>
-          <p:cNvSpPr txBox="1"/>
-          <p:nvPr/>
-        </p:nvSpPr>
-        <p:spPr>
-          <a:xfrm>
-            <a:off x="508000" y="3280664"/>
-            <a:ext cx="3810000" cy="346964"/>
-          </a:xfrm>
-          <a:prstGeom prst="rect">
-            <a:avLst/>
-          </a:prstGeom>
-          <a:noFill/>
-        </p:spPr>
-        <p:txBody>
-          <a:bodyPr wrap="none" lIns="0" rIns="0" tIns="0" bIns="0" anchor="t">
-            <a:spAutoFit/>
-          </a:bodyPr>
-          <a:lstStyle/>
-          <a:p>
-            <a:pPr>
-              <a:defRPr sz="1800" b="0">
+              <a:t>Por temporada, según el modelo. No se suman.</a:t>
+            </a:r>
+          </a:p>
+        </p:txBody>
+      </p:sp>
+      <p:sp>
+        <p:nvSpPr>
+          <p:cNvPr id="17" name="TextBox 16"/>
+          <p:cNvSpPr txBox="1"/>
+          <p:nvPr/>
+        </p:nvSpPr>
+        <p:spPr>
+          <a:xfrm>
+            <a:off x="508000" y="4036567"/>
+            <a:ext cx="8128000" cy="315468"/>
+          </a:xfrm>
+          <a:prstGeom prst="rect">
+            <a:avLst/>
+          </a:prstGeom>
+          <a:noFill/>
+        </p:spPr>
+        <p:txBody>
+          <a:bodyPr wrap="none" lIns="0" rIns="0" tIns="0" bIns="0" anchor="t">
+            <a:spAutoFit/>
+          </a:bodyPr>
+          <a:lstStyle/>
+          <a:p>
+            <a:pPr>
+              <a:defRPr sz="1600" b="0">
                 <a:solidFill>
                   <a:srgbClr val="202124"/>
                 </a:solidFill>
@@ -8168,223 +8384,7 @@
               </a:defRPr>
             </a:pPr>
             <a:r>
-              <a:t>La identidad del Harp Helú</a:t>
-            </a:r>
-          </a:p>
-        </p:txBody>
-      </p:sp>
-      <p:sp>
-        <p:nvSpPr>
-          <p:cNvPr id="12" name="TextBox 11"/>
-          <p:cNvSpPr txBox="1"/>
-          <p:nvPr/>
-        </p:nvSpPr>
-        <p:spPr>
-          <a:xfrm>
-            <a:off x="508000" y="3564128"/>
-            <a:ext cx="3810000" cy="346964"/>
-          </a:xfrm>
-          <a:prstGeom prst="rect">
-            <a:avLst/>
-          </a:prstGeom>
-          <a:noFill/>
-        </p:spPr>
-        <p:txBody>
-          <a:bodyPr wrap="none" lIns="0" rIns="0" tIns="0" bIns="0" anchor="t">
-            <a:spAutoFit/>
-          </a:bodyPr>
-          <a:lstStyle/>
-          <a:p>
-            <a:pPr>
-              <a:defRPr sz="1800" b="0">
-                <a:solidFill>
-                  <a:srgbClr val="202124"/>
-                </a:solidFill>
-                <a:latin typeface="Arial"/>
-              </a:defRPr>
-            </a:pPr>
-            <a:r>
-              <a:t>sigue sin verificarse.</a:t>
-            </a:r>
-          </a:p>
-        </p:txBody>
-      </p:sp>
-      <p:sp>
-        <p:nvSpPr>
-          <p:cNvPr id="13" name="TextBox 12"/>
-          <p:cNvSpPr txBox="1"/>
-          <p:nvPr/>
-        </p:nvSpPr>
-        <p:spPr>
-          <a:xfrm>
-            <a:off x="4826000" y="1828800"/>
-            <a:ext cx="3810000" cy="409956"/>
-          </a:xfrm>
-          <a:prstGeom prst="rect">
-            <a:avLst/>
-          </a:prstGeom>
-          <a:noFill/>
-        </p:spPr>
-        <p:txBody>
-          <a:bodyPr wrap="none" lIns="0" rIns="0" tIns="0" bIns="0" anchor="t">
-            <a:spAutoFit/>
-          </a:bodyPr>
-          <a:lstStyle/>
-          <a:p>
-            <a:pPr>
-              <a:defRPr sz="2200" b="1">
-                <a:solidFill>
-                  <a:srgbClr val="D71920"/>
-                </a:solidFill>
-                <a:latin typeface="Arial"/>
-              </a:defRPr>
-            </a:pPr>
-            <a:r>
-              <a:t>Antes de recomendar uso</a:t>
-            </a:r>
-          </a:p>
-        </p:txBody>
-      </p:sp>
-      <p:sp>
-        <p:nvSpPr>
-          <p:cNvPr id="14" name="TextBox 13"/>
-          <p:cNvSpPr txBox="1"/>
-          <p:nvPr/>
-        </p:nvSpPr>
-        <p:spPr>
-          <a:xfrm>
-            <a:off x="4826000" y="2413000"/>
-            <a:ext cx="3810000" cy="362712"/>
-          </a:xfrm>
-          <a:prstGeom prst="rect">
-            <a:avLst/>
-          </a:prstGeom>
-          <a:noFill/>
-        </p:spPr>
-        <p:txBody>
-          <a:bodyPr wrap="none" lIns="0" rIns="0" tIns="0" bIns="0" anchor="t">
-            <a:spAutoFit/>
-          </a:bodyPr>
-          <a:lstStyle/>
-          <a:p>
-            <a:pPr>
-              <a:defRPr sz="1900" b="0">
-                <a:solidFill>
-                  <a:srgbClr val="202124"/>
-                </a:solidFill>
-                <a:latin typeface="Arial"/>
-              </a:defRPr>
-            </a:pPr>
-            <a:r>
-              <a:t>Confirmar equipo y estadio.</a:t>
-            </a:r>
-          </a:p>
-        </p:txBody>
-      </p:sp>
-      <p:sp>
-        <p:nvSpPr>
-          <p:cNvPr id="15" name="TextBox 14"/>
-          <p:cNvSpPr txBox="1"/>
-          <p:nvPr/>
-        </p:nvSpPr>
-        <p:spPr>
-          <a:xfrm>
-            <a:off x="4826000" y="2712212"/>
-            <a:ext cx="3810000" cy="362712"/>
-          </a:xfrm>
-          <a:prstGeom prst="rect">
-            <a:avLst/>
-          </a:prstGeom>
-          <a:noFill/>
-        </p:spPr>
-        <p:txBody>
-          <a:bodyPr wrap="none" lIns="0" rIns="0" tIns="0" bIns="0" anchor="t">
-            <a:spAutoFit/>
-          </a:bodyPr>
-          <a:lstStyle/>
-          <a:p>
-            <a:pPr>
-              <a:defRPr sz="1900" b="0">
-                <a:solidFill>
-                  <a:srgbClr val="202124"/>
-                </a:solidFill>
-                <a:latin typeface="Arial"/>
-              </a:defRPr>
-            </a:pPr>
-            <a:r>
-              <a:t>Vincular arsenal por temporada.</a:t>
-            </a:r>
-          </a:p>
-        </p:txBody>
-      </p:sp>
-      <p:sp>
-        <p:nvSpPr>
-          <p:cNvPr id="16" name="TextBox 15"/>
-          <p:cNvSpPr txBox="1"/>
-          <p:nvPr/>
-        </p:nvSpPr>
-        <p:spPr>
-          <a:xfrm>
-            <a:off x="4826000" y="3011424"/>
-            <a:ext cx="3810000" cy="362712"/>
-          </a:xfrm>
-          <a:prstGeom prst="rect">
-            <a:avLst/>
-          </a:prstGeom>
-          <a:noFill/>
-        </p:spPr>
-        <p:txBody>
-          <a:bodyPr wrap="none" lIns="0" rIns="0" tIns="0" bIns="0" anchor="t">
-            <a:spAutoFit/>
-          </a:bodyPr>
-          <a:lstStyle/>
-          <a:p>
-            <a:pPr>
-              <a:defRPr sz="1900" b="0">
-                <a:solidFill>
-                  <a:srgbClr val="202124"/>
-                </a:solidFill>
-                <a:latin typeface="Arial"/>
-              </a:defRPr>
-            </a:pPr>
-            <a:r>
-              <a:t>Revisar el split casa y gira</a:t>
-            </a:r>
-          </a:p>
-        </p:txBody>
-      </p:sp>
-      <p:sp>
-        <p:nvSpPr>
-          <p:cNvPr id="17" name="TextBox 16"/>
-          <p:cNvSpPr txBox="1"/>
-          <p:nvPr/>
-        </p:nvSpPr>
-        <p:spPr>
-          <a:xfrm>
-            <a:off x="4826000" y="3310636"/>
-            <a:ext cx="3810000" cy="362712"/>
-          </a:xfrm>
-          <a:prstGeom prst="rect">
-            <a:avLst/>
-          </a:prstGeom>
-          <a:noFill/>
-        </p:spPr>
-        <p:txBody>
-          <a:bodyPr wrap="none" lIns="0" rIns="0" tIns="0" bIns="0" anchor="t">
-            <a:spAutoFit/>
-          </a:bodyPr>
-          <a:lstStyle/>
-          <a:p>
-            <a:pPr>
-              <a:defRPr sz="1900" b="0">
-                <a:solidFill>
-                  <a:srgbClr val="202124"/>
-                </a:solidFill>
-                <a:latin typeface="Arial"/>
-              </a:defRPr>
-            </a:pPr>
-            <a:r>
-              <a:t>y su cobertura.</a:t>
+              <a:t>La sede sigue sin confirmarse.</a:t>
             </a:r>
           </a:p>
         </p:txBody>
@@ -8532,7 +8532,7 @@
               </a:defRPr>
             </a:pPr>
             <a:r>
-              <a:t>El prospecto comienza con un perfil físico</a:t>
+              <a:t>El prospecto se mide en el aire de casa</a:t>
             </a:r>
           </a:p>
         </p:txBody>
@@ -8568,7 +8568,7 @@
               </a:defRPr>
             </a:pPr>
             <a:r>
-              <a:t>Contrato: docs/CONTRACT.md; stuffplus/schema.py. Flujo propuesto, sin evaluación real de prospectos.</a:t>
+              <a:t>reports/ideal_profile/best_fastballs.csv · recta de rango 1 por Stuff+ en el Harp Helú.</a:t>
             </a:r>
           </a:p>
         </p:txBody>
@@ -8618,21 +8618,21 @@
         <p:spPr>
           <a:xfrm>
             <a:off x="508000" y="1828800"/>
-            <a:ext cx="3556000" cy="409956"/>
-          </a:xfrm>
-          <a:prstGeom prst="rect">
-            <a:avLst/>
-          </a:prstGeom>
-          <a:noFill/>
-        </p:spPr>
-        <p:txBody>
-          <a:bodyPr wrap="none" lIns="0" rIns="0" tIns="0" bIns="0" anchor="t">
-            <a:spAutoFit/>
-          </a:bodyPr>
-          <a:lstStyle/>
-          <a:p>
-            <a:pPr>
-              <a:defRPr sz="2200" b="1">
+            <a:ext cx="3556000" cy="882396"/>
+          </a:xfrm>
+          <a:prstGeom prst="rect">
+            <a:avLst/>
+          </a:prstGeom>
+          <a:noFill/>
+        </p:spPr>
+        <p:txBody>
+          <a:bodyPr wrap="none" lIns="0" rIns="0" tIns="0" bIns="0" anchor="t">
+            <a:spAutoFit/>
+          </a:bodyPr>
+          <a:lstStyle/>
+          <a:p>
+            <a:pPr>
+              <a:defRPr sz="5200" b="1">
                 <a:solidFill>
                   <a:srgbClr val="D71920"/>
                 </a:solidFill>
@@ -8640,7 +8640,7 @@
               </a:defRPr>
             </a:pPr>
             <a:r>
-              <a:t>Entrada</a:t>
+              <a:t>108.2</a:t>
             </a:r>
           </a:p>
         </p:txBody>
@@ -8653,22 +8653,22 @@
         </p:nvSpPr>
         <p:spPr>
           <a:xfrm>
-            <a:off x="508000" y="2387600"/>
-            <a:ext cx="3556000" cy="378460"/>
-          </a:xfrm>
-          <a:prstGeom prst="rect">
-            <a:avLst/>
-          </a:prstGeom>
-          <a:noFill/>
-        </p:spPr>
-        <p:txBody>
-          <a:bodyPr wrap="none" lIns="0" rIns="0" tIns="0" bIns="0" anchor="t">
-            <a:spAutoFit/>
-          </a:bodyPr>
-          <a:lstStyle/>
-          <a:p>
-            <a:pPr>
-              <a:defRPr sz="2000" b="0">
+            <a:off x="508000" y="2692400"/>
+            <a:ext cx="3556000" cy="346964"/>
+          </a:xfrm>
+          <a:prstGeom prst="rect">
+            <a:avLst/>
+          </a:prstGeom>
+          <a:noFill/>
+        </p:spPr>
+        <p:txBody>
+          <a:bodyPr wrap="none" lIns="0" rIns="0" tIns="0" bIns="0" anchor="t">
+            <a:spAutoFit/>
+          </a:bodyPr>
+          <a:lstStyle/>
+          <a:p>
+            <a:pPr>
+              <a:defRPr sz="1800" b="0">
                 <a:solidFill>
                   <a:srgbClr val="202124"/>
                 </a:solidFill>
@@ -8676,7 +8676,7 @@
               </a:defRPr>
             </a:pPr>
             <a:r>
-              <a:t>Velocidad y giro</a:t>
+              <a:t>Stuff+ en el Harp Helú</a:t>
             </a:r>
           </a:p>
         </p:txBody>
@@ -8689,22 +8689,22 @@
         </p:nvSpPr>
         <p:spPr>
           <a:xfrm>
-            <a:off x="508000" y="2702560"/>
-            <a:ext cx="3556000" cy="378460"/>
-          </a:xfrm>
-          <a:prstGeom prst="rect">
-            <a:avLst/>
-          </a:prstGeom>
-          <a:noFill/>
-        </p:spPr>
-        <p:txBody>
-          <a:bodyPr wrap="none" lIns="0" rIns="0" tIns="0" bIns="0" anchor="t">
-            <a:spAutoFit/>
-          </a:bodyPr>
-          <a:lstStyle/>
-          <a:p>
-            <a:pPr>
-              <a:defRPr sz="2000" b="0">
+            <a:off x="508000" y="2975864"/>
+            <a:ext cx="3556000" cy="346964"/>
+          </a:xfrm>
+          <a:prstGeom prst="rect">
+            <a:avLst/>
+          </a:prstGeom>
+          <a:noFill/>
+        </p:spPr>
+        <p:txBody>
+          <a:bodyPr wrap="none" lIns="0" rIns="0" tIns="0" bIns="0" anchor="t">
+            <a:spAutoFit/>
+          </a:bodyPr>
+          <a:lstStyle/>
+          <a:p>
+            <a:pPr>
+              <a:defRPr sz="1800" b="0">
                 <a:solidFill>
                   <a:srgbClr val="202124"/>
                 </a:solidFill>
@@ -8712,7 +8712,7 @@
               </a:defRPr>
             </a:pPr>
             <a:r>
-              <a:t>Eje de giro</a:t>
+              <a:t>Recta de referencia</a:t>
             </a:r>
           </a:p>
         </p:txBody>
@@ -8725,22 +8725,58 @@
         </p:nvSpPr>
         <p:spPr>
           <a:xfrm>
-            <a:off x="508000" y="3017520"/>
-            <a:ext cx="3556000" cy="378460"/>
-          </a:xfrm>
-          <a:prstGeom prst="rect">
-            <a:avLst/>
-          </a:prstGeom>
-          <a:noFill/>
-        </p:spPr>
-        <p:txBody>
-          <a:bodyPr wrap="none" lIns="0" rIns="0" tIns="0" bIns="0" anchor="t">
-            <a:spAutoFit/>
-          </a:bodyPr>
-          <a:lstStyle/>
-          <a:p>
-            <a:pPr>
-              <a:defRPr sz="2000" b="0">
+            <a:off x="4826000" y="1828800"/>
+            <a:ext cx="3556000" cy="882396"/>
+          </a:xfrm>
+          <a:prstGeom prst="rect">
+            <a:avLst/>
+          </a:prstGeom>
+          <a:noFill/>
+        </p:spPr>
+        <p:txBody>
+          <a:bodyPr wrap="none" lIns="0" rIns="0" tIns="0" bIns="0" anchor="t">
+            <a:spAutoFit/>
+          </a:bodyPr>
+          <a:lstStyle/>
+          <a:p>
+            <a:pPr>
+              <a:defRPr sz="5200" b="1">
+                <a:solidFill>
+                  <a:srgbClr val="D71920"/>
+                </a:solidFill>
+                <a:latin typeface="Arial"/>
+              </a:defRPr>
+            </a:pPr>
+            <a:r>
+              <a:t>115.5</a:t>
+            </a:r>
+          </a:p>
+        </p:txBody>
+      </p:sp>
+      <p:sp>
+        <p:nvSpPr>
+          <p:cNvPr id="12" name="TextBox 11"/>
+          <p:cNvSpPr txBox="1"/>
+          <p:nvPr/>
+        </p:nvSpPr>
+        <p:spPr>
+          <a:xfrm>
+            <a:off x="4826000" y="2692400"/>
+            <a:ext cx="3556000" cy="346964"/>
+          </a:xfrm>
+          <a:prstGeom prst="rect">
+            <a:avLst/>
+          </a:prstGeom>
+          <a:noFill/>
+        </p:spPr>
+        <p:txBody>
+          <a:bodyPr wrap="none" lIns="0" rIns="0" tIns="0" bIns="0" anchor="t">
+            <a:spAutoFit/>
+          </a:bodyPr>
+          <a:lstStyle/>
+          <a:p>
+            <a:pPr>
+              <a:defRPr sz="1800" b="0">
                 <a:solidFill>
                   <a:srgbClr val="202124"/>
                 </a:solidFill>
@@ -8748,35 +8784,35 @@
               </a:defRPr>
             </a:pPr>
             <a:r>
-              <a:t>Punto de liberación</a:t>
-            </a:r>
-          </a:p>
-        </p:txBody>
-      </p:sp>
-      <p:sp>
-        <p:nvSpPr>
-          <p:cNvPr id="12" name="TextBox 11"/>
-          <p:cNvSpPr txBox="1"/>
-          <p:nvPr/>
-        </p:nvSpPr>
-        <p:spPr>
-          <a:xfrm>
-            <a:off x="508000" y="3332479"/>
-            <a:ext cx="3556000" cy="378460"/>
-          </a:xfrm>
-          <a:prstGeom prst="rect">
-            <a:avLst/>
-          </a:prstGeom>
-          <a:noFill/>
-        </p:spPr>
-        <p:txBody>
-          <a:bodyPr wrap="none" lIns="0" rIns="0" tIns="0" bIns="0" anchor="t">
-            <a:spAutoFit/>
-          </a:bodyPr>
-          <a:lstStyle/>
-          <a:p>
-            <a:pPr>
-              <a:defRPr sz="2000" b="0">
+              <a:t>Stuff+ a nivel del mar</a:t>
+            </a:r>
+          </a:p>
+        </p:txBody>
+      </p:sp>
+      <p:sp>
+        <p:nvSpPr>
+          <p:cNvPr id="13" name="TextBox 12"/>
+          <p:cNvSpPr txBox="1"/>
+          <p:nvPr/>
+        </p:nvSpPr>
+        <p:spPr>
+          <a:xfrm>
+            <a:off x="4826000" y="2975864"/>
+            <a:ext cx="3556000" cy="346964"/>
+          </a:xfrm>
+          <a:prstGeom prst="rect">
+            <a:avLst/>
+          </a:prstGeom>
+          <a:noFill/>
+        </p:spPr>
+        <p:txBody>
+          <a:bodyPr wrap="none" lIns="0" rIns="0" tIns="0" bIns="0" anchor="t">
+            <a:spAutoFit/>
+          </a:bodyPr>
+          <a:lstStyle/>
+          <a:p>
+            <a:pPr>
+              <a:defRPr sz="1800" b="0">
                 <a:solidFill>
                   <a:srgbClr val="202124"/>
                 </a:solidFill>
@@ -8784,43 +8820,7 @@
               </a:defRPr>
             </a:pPr>
             <a:r>
-              <a:t>Extensión y uso del arsenal</a:t>
-            </a:r>
-          </a:p>
-        </p:txBody>
-      </p:sp>
-      <p:sp>
-        <p:nvSpPr>
-          <p:cNvPr id="13" name="TextBox 12"/>
-          <p:cNvSpPr txBox="1"/>
-          <p:nvPr/>
-        </p:nvSpPr>
-        <p:spPr>
-          <a:xfrm>
-            <a:off x="4826000" y="1828800"/>
-            <a:ext cx="3810000" cy="409956"/>
-          </a:xfrm>
-          <a:prstGeom prst="rect">
-            <a:avLst/>
-          </a:prstGeom>
-          <a:noFill/>
-        </p:spPr>
-        <p:txBody>
-          <a:bodyPr wrap="none" lIns="0" rIns="0" tIns="0" bIns="0" anchor="t">
-            <a:spAutoFit/>
-          </a:bodyPr>
-          <a:lstStyle/>
-          <a:p>
-            <a:pPr>
-              <a:defRPr sz="2200" b="1">
-                <a:solidFill>
-                  <a:srgbClr val="D71920"/>
-                </a:solidFill>
-                <a:latin typeface="Arial"/>
-              </a:defRPr>
-            </a:pPr>
-            <a:r>
-              <a:t>Discusión con scouting</a:t>
+              <a:t>La misma recta</a:t>
             </a:r>
           </a:p>
         </p:txBody>
@@ -8833,166 +8833,22 @@
         </p:nvSpPr>
         <p:spPr>
           <a:xfrm>
-            <a:off x="4826000" y="2387600"/>
-            <a:ext cx="3810000" cy="378460"/>
-          </a:xfrm>
-          <a:prstGeom prst="rect">
-            <a:avLst/>
-          </a:prstGeom>
-          <a:noFill/>
-        </p:spPr>
-        <p:txBody>
-          <a:bodyPr wrap="none" lIns="0" rIns="0" tIns="0" bIns="0" anchor="t">
-            <a:spAutoFit/>
-          </a:bodyPr>
-          <a:lstStyle/>
-          <a:p>
-            <a:pPr>
-              <a:defRPr sz="2000" b="0">
-                <a:solidFill>
-                  <a:srgbClr val="202124"/>
-                </a:solidFill>
-                <a:latin typeface="Arial"/>
-              </a:defRPr>
-            </a:pPr>
-            <a:r>
-              <a:t>Cambio de movimiento</a:t>
-            </a:r>
-          </a:p>
-        </p:txBody>
-      </p:sp>
-      <p:sp>
-        <p:nvSpPr>
-          <p:cNvPr id="15" name="TextBox 14"/>
-          <p:cNvSpPr txBox="1"/>
-          <p:nvPr/>
-        </p:nvSpPr>
-        <p:spPr>
-          <a:xfrm>
-            <a:off x="4826000" y="2702560"/>
-            <a:ext cx="3810000" cy="378460"/>
-          </a:xfrm>
-          <a:prstGeom prst="rect">
-            <a:avLst/>
-          </a:prstGeom>
-          <a:noFill/>
-        </p:spPr>
-        <p:txBody>
-          <a:bodyPr wrap="none" lIns="0" rIns="0" tIns="0" bIns="0" anchor="t">
-            <a:spAutoFit/>
-          </a:bodyPr>
-          <a:lstStyle/>
-          <a:p>
-            <a:pPr>
-              <a:defRPr sz="2000" b="0">
-                <a:solidFill>
-                  <a:srgbClr val="202124"/>
-                </a:solidFill>
-                <a:latin typeface="Arial"/>
-              </a:defRPr>
-            </a:pPr>
-            <a:r>
-              <a:t>Calidad en ambos ambientes</a:t>
-            </a:r>
-          </a:p>
-        </p:txBody>
-      </p:sp>
-      <p:sp>
-        <p:nvSpPr>
-          <p:cNvPr id="16" name="TextBox 15"/>
-          <p:cNvSpPr txBox="1"/>
-          <p:nvPr/>
-        </p:nvSpPr>
-        <p:spPr>
-          <a:xfrm>
-            <a:off x="4826000" y="3017520"/>
-            <a:ext cx="3810000" cy="378460"/>
-          </a:xfrm>
-          <a:prstGeom prst="rect">
-            <a:avLst/>
-          </a:prstGeom>
-          <a:noFill/>
-        </p:spPr>
-        <p:txBody>
-          <a:bodyPr wrap="none" lIns="0" rIns="0" tIns="0" bIns="0" anchor="t">
-            <a:spAutoFit/>
-          </a:bodyPr>
-          <a:lstStyle/>
-          <a:p>
-            <a:pPr>
-              <a:defRPr sz="2000" b="0">
-                <a:solidFill>
-                  <a:srgbClr val="202124"/>
-                </a:solidFill>
-                <a:latin typeface="Arial"/>
-              </a:defRPr>
-            </a:pPr>
-            <a:r>
-              <a:t>Cobertura e incertidumbre</a:t>
-            </a:r>
-          </a:p>
-        </p:txBody>
-      </p:sp>
-      <p:sp>
-        <p:nvSpPr>
-          <p:cNvPr id="17" name="TextBox 16"/>
-          <p:cNvSpPr txBox="1"/>
-          <p:nvPr/>
-        </p:nvSpPr>
-        <p:spPr>
-          <a:xfrm>
-            <a:off x="4826000" y="3332479"/>
-            <a:ext cx="3810000" cy="378460"/>
-          </a:xfrm>
-          <a:prstGeom prst="rect">
-            <a:avLst/>
-          </a:prstGeom>
-          <a:noFill/>
-        </p:spPr>
-        <p:txBody>
-          <a:bodyPr wrap="none" lIns="0" rIns="0" tIns="0" bIns="0" anchor="t">
-            <a:spAutoFit/>
-          </a:bodyPr>
-          <a:lstStyle/>
-          <a:p>
-            <a:pPr>
-              <a:defRPr sz="2000" b="0">
-                <a:solidFill>
-                  <a:srgbClr val="202124"/>
-                </a:solidFill>
-                <a:latin typeface="Arial"/>
-              </a:defRPr>
-            </a:pPr>
-            <a:r>
-              <a:t>Necesidades de desarrollo</a:t>
-            </a:r>
-          </a:p>
-        </p:txBody>
-      </p:sp>
-      <p:sp>
-        <p:nvSpPr>
-          <p:cNvPr id="18" name="TextBox 17"/>
-          <p:cNvSpPr txBox="1"/>
-          <p:nvPr/>
-        </p:nvSpPr>
-        <p:spPr>
-          <a:xfrm>
-            <a:off x="508000" y="4152900"/>
-            <a:ext cx="8128000" cy="283972"/>
-          </a:xfrm>
-          <a:prstGeom prst="rect">
-            <a:avLst/>
-          </a:prstGeom>
-          <a:noFill/>
-        </p:spPr>
-        <p:txBody>
-          <a:bodyPr wrap="none" lIns="0" rIns="0" tIns="0" bIns="0" anchor="t">
-            <a:spAutoFit/>
-          </a:bodyPr>
-          <a:lstStyle/>
-          <a:p>
-            <a:pPr>
-              <a:defRPr sz="1400" b="0">
+            <a:off x="508000" y="3937000"/>
+            <a:ext cx="8128000" cy="299720"/>
+          </a:xfrm>
+          <a:prstGeom prst="rect">
+            <a:avLst/>
+          </a:prstGeom>
+          <a:noFill/>
+        </p:spPr>
+        <p:txBody>
+          <a:bodyPr wrap="none" lIns="0" rIns="0" tIns="0" bIns="0" anchor="t">
+            <a:spAutoFit/>
+          </a:bodyPr>
+          <a:lstStyle/>
+          <a:p>
+            <a:pPr>
+              <a:defRPr sz="1500" b="0">
                 <a:solidFill>
                   <a:srgbClr val="585B60"/>
                 </a:solidFill>
@@ -9000,7 +8856,7 @@
               </a:defRPr>
             </a:pPr>
             <a:r>
-              <a:t>Evaluador y comparables pendientes. Este flujo no constituye un dictamen.</a:t>
+              <a:t>El perfilador compara el arsenal en los dos aires. Esto no es un dictamen con nombre.</a:t>
             </a:r>
           </a:p>
         </p:txBody>
@@ -9184,7 +9040,7 @@
               </a:defRPr>
             </a:pPr>
             <a:r>
-              <a:t>reports/business_value/runs_per_win.csv · aproximación pitagórica; no proyección de ahorro del staff.</a:t>
+              <a:t>reports/business_value/runs_per_win.csv; reports/business_value/runs_per_point_direct.csv · Stuff+, rv_x, fuera de muestra.</a:t>
             </a:r>
           </a:p>
         </p:txBody>
@@ -9233,22 +9089,22 @@
         </p:nvSpPr>
         <p:spPr>
           <a:xfrm>
-            <a:off x="508000" y="1828800"/>
-            <a:ext cx="3810000" cy="898144"/>
-          </a:xfrm>
-          <a:prstGeom prst="rect">
-            <a:avLst/>
-          </a:prstGeom>
-          <a:noFill/>
-        </p:spPr>
-        <p:txBody>
-          <a:bodyPr wrap="none" lIns="0" rIns="0" tIns="0" bIns="0" anchor="t">
-            <a:spAutoFit/>
-          </a:bodyPr>
-          <a:lstStyle/>
-          <a:p>
-            <a:pPr>
-              <a:defRPr sz="5300" b="1">
+            <a:off x="508000" y="1752600"/>
+            <a:ext cx="2540000" cy="787908"/>
+          </a:xfrm>
+          <a:prstGeom prst="rect">
+            <a:avLst/>
+          </a:prstGeom>
+          <a:noFill/>
+        </p:spPr>
+        <p:txBody>
+          <a:bodyPr wrap="none" lIns="0" rIns="0" tIns="0" bIns="0" anchor="t">
+            <a:spAutoFit/>
+          </a:bodyPr>
+          <a:lstStyle/>
+          <a:p>
+            <a:pPr>
+              <a:defRPr sz="4600" b="1">
                 <a:solidFill>
                   <a:srgbClr val="D71920"/>
                 </a:solidFill>
@@ -9269,22 +9125,22 @@
         </p:nvSpPr>
         <p:spPr>
           <a:xfrm>
-            <a:off x="508000" y="2743200"/>
-            <a:ext cx="3810000" cy="378460"/>
-          </a:xfrm>
-          <a:prstGeom prst="rect">
-            <a:avLst/>
-          </a:prstGeom>
-          <a:noFill/>
-        </p:spPr>
-        <p:txBody>
-          <a:bodyPr wrap="none" lIns="0" rIns="0" tIns="0" bIns="0" anchor="t">
-            <a:spAutoFit/>
-          </a:bodyPr>
-          <a:lstStyle/>
-          <a:p>
-            <a:pPr>
-              <a:defRPr sz="2000" b="0">
+            <a:off x="508000" y="2489200"/>
+            <a:ext cx="2540000" cy="315468"/>
+          </a:xfrm>
+          <a:prstGeom prst="rect">
+            <a:avLst/>
+          </a:prstGeom>
+          <a:noFill/>
+        </p:spPr>
+        <p:txBody>
+          <a:bodyPr wrap="none" lIns="0" rIns="0" tIns="0" bIns="0" anchor="t">
+            <a:spAutoFit/>
+          </a:bodyPr>
+          <a:lstStyle/>
+          <a:p>
+            <a:pPr>
+              <a:defRPr sz="1600" b="0">
                 <a:solidFill>
                   <a:srgbClr val="202124"/>
                 </a:solidFill>
@@ -9305,22 +9161,22 @@
         </p:nvSpPr>
         <p:spPr>
           <a:xfrm>
-            <a:off x="508000" y="3058160"/>
-            <a:ext cx="3810000" cy="378460"/>
-          </a:xfrm>
-          <a:prstGeom prst="rect">
-            <a:avLst/>
-          </a:prstGeom>
-          <a:noFill/>
-        </p:spPr>
-        <p:txBody>
-          <a:bodyPr wrap="none" lIns="0" rIns="0" tIns="0" bIns="0" anchor="t">
-            <a:spAutoFit/>
-          </a:bodyPr>
-          <a:lstStyle/>
-          <a:p>
-            <a:pPr>
-              <a:defRPr sz="2000" b="0">
+            <a:off x="508000" y="2741168"/>
+            <a:ext cx="2540000" cy="315468"/>
+          </a:xfrm>
+          <a:prstGeom prst="rect">
+            <a:avLst/>
+          </a:prstGeom>
+          <a:noFill/>
+        </p:spPr>
+        <p:txBody>
+          <a:bodyPr wrap="none" lIns="0" rIns="0" tIns="0" bIns="0" anchor="t">
+            <a:spAutoFit/>
+          </a:bodyPr>
+          <a:lstStyle/>
+          <a:p>
+            <a:pPr>
+              <a:defRPr sz="1600" b="0">
                 <a:solidFill>
                   <a:srgbClr val="202124"/>
                 </a:solidFill>
@@ -9341,22 +9197,22 @@
         </p:nvSpPr>
         <p:spPr>
           <a:xfrm>
-            <a:off x="4826000" y="1828800"/>
-            <a:ext cx="3810000" cy="898144"/>
-          </a:xfrm>
-          <a:prstGeom prst="rect">
-            <a:avLst/>
-          </a:prstGeom>
-          <a:noFill/>
-        </p:spPr>
-        <p:txBody>
-          <a:bodyPr wrap="none" lIns="0" rIns="0" tIns="0" bIns="0" anchor="t">
-            <a:spAutoFit/>
-          </a:bodyPr>
-          <a:lstStyle/>
-          <a:p>
-            <a:pPr>
-              <a:defRPr sz="5300" b="1">
+            <a:off x="3175000" y="1752600"/>
+            <a:ext cx="2540000" cy="787908"/>
+          </a:xfrm>
+          <a:prstGeom prst="rect">
+            <a:avLst/>
+          </a:prstGeom>
+          <a:noFill/>
+        </p:spPr>
+        <p:txBody>
+          <a:bodyPr wrap="none" lIns="0" rIns="0" tIns="0" bIns="0" anchor="t">
+            <a:spAutoFit/>
+          </a:bodyPr>
+          <a:lstStyle/>
+          <a:p>
+            <a:pPr>
+              <a:defRPr sz="4600" b="1">
                 <a:solidFill>
                   <a:srgbClr val="D71920"/>
                 </a:solidFill>
@@ -9377,22 +9233,22 @@
         </p:nvSpPr>
         <p:spPr>
           <a:xfrm>
-            <a:off x="4826000" y="2743200"/>
-            <a:ext cx="3810000" cy="378460"/>
-          </a:xfrm>
-          <a:prstGeom prst="rect">
-            <a:avLst/>
-          </a:prstGeom>
-          <a:noFill/>
-        </p:spPr>
-        <p:txBody>
-          <a:bodyPr wrap="none" lIns="0" rIns="0" tIns="0" bIns="0" anchor="t">
-            <a:spAutoFit/>
-          </a:bodyPr>
-          <a:lstStyle/>
-          <a:p>
-            <a:pPr>
-              <a:defRPr sz="2000" b="0">
+            <a:off x="3175000" y="2489200"/>
+            <a:ext cx="2667000" cy="315468"/>
+          </a:xfrm>
+          <a:prstGeom prst="rect">
+            <a:avLst/>
+          </a:prstGeom>
+          <a:noFill/>
+        </p:spPr>
+        <p:txBody>
+          <a:bodyPr wrap="none" lIns="0" rIns="0" tIns="0" bIns="0" anchor="t">
+            <a:spAutoFit/>
+          </a:bodyPr>
+          <a:lstStyle/>
+          <a:p>
+            <a:pPr>
+              <a:defRPr sz="1600" b="0">
                 <a:solidFill>
                   <a:srgbClr val="202124"/>
                 </a:solidFill>
@@ -9413,22 +9269,22 @@
         </p:nvSpPr>
         <p:spPr>
           <a:xfrm>
-            <a:off x="4826000" y="3058160"/>
-            <a:ext cx="3810000" cy="378460"/>
-          </a:xfrm>
-          <a:prstGeom prst="rect">
-            <a:avLst/>
-          </a:prstGeom>
-          <a:noFill/>
-        </p:spPr>
-        <p:txBody>
-          <a:bodyPr wrap="none" lIns="0" rIns="0" tIns="0" bIns="0" anchor="t">
-            <a:spAutoFit/>
-          </a:bodyPr>
-          <a:lstStyle/>
-          <a:p>
-            <a:pPr>
-              <a:defRPr sz="2000" b="0">
+            <a:off x="3175000" y="2741168"/>
+            <a:ext cx="2667000" cy="315468"/>
+          </a:xfrm>
+          <a:prstGeom prst="rect">
+            <a:avLst/>
+          </a:prstGeom>
+          <a:noFill/>
+        </p:spPr>
+        <p:txBody>
+          <a:bodyPr wrap="none" lIns="0" rIns="0" tIns="0" bIns="0" anchor="t">
+            <a:spAutoFit/>
+          </a:bodyPr>
+          <a:lstStyle/>
+          <a:p>
+            <a:pPr>
+              <a:defRPr sz="1600" b="0">
                 <a:solidFill>
                   <a:srgbClr val="202124"/>
                 </a:solidFill>
@@ -9449,22 +9305,58 @@
         </p:nvSpPr>
         <p:spPr>
           <a:xfrm>
-            <a:off x="508000" y="3835400"/>
-            <a:ext cx="8128000" cy="346964"/>
-          </a:xfrm>
-          <a:prstGeom prst="rect">
-            <a:avLst/>
-          </a:prstGeom>
-          <a:noFill/>
-        </p:spPr>
-        <p:txBody>
-          <a:bodyPr wrap="none" lIns="0" rIns="0" tIns="0" bIns="0" anchor="t">
-            <a:spAutoFit/>
-          </a:bodyPr>
-          <a:lstStyle/>
-          <a:p>
-            <a:pPr>
-              <a:defRPr sz="1800" b="1">
+            <a:off x="6223000" y="1752600"/>
+            <a:ext cx="2413000" cy="469900"/>
+          </a:xfrm>
+          <a:prstGeom prst="rect">
+            <a:avLst/>
+          </a:prstGeom>
+          <a:noFill/>
+        </p:spPr>
+        <p:txBody>
+          <a:bodyPr wrap="none" lIns="0" rIns="0" tIns="0" bIns="0" anchor="t">
+            <a:spAutoFit/>
+          </a:bodyPr>
+          <a:lstStyle/>
+          <a:p>
+            <a:pPr>
+              <a:defRPr sz="2800" b="1">
+                <a:solidFill>
+                  <a:srgbClr val="D71920"/>
+                </a:solidFill>
+                <a:latin typeface="Arial"/>
+              </a:defRPr>
+            </a:pPr>
+            <a:r>
+              <a:t>0.000724</a:t>
+            </a:r>
+          </a:p>
+        </p:txBody>
+      </p:sp>
+      <p:sp>
+        <p:nvSpPr>
+          <p:cNvPr id="15" name="TextBox 14"/>
+          <p:cNvSpPr txBox="1"/>
+          <p:nvPr/>
+        </p:nvSpPr>
+        <p:spPr>
+          <a:xfrm>
+            <a:off x="6223000" y="2489200"/>
+            <a:ext cx="2413000" cy="315468"/>
+          </a:xfrm>
+          <a:prstGeom prst="rect">
+            <a:avLst/>
+          </a:prstGeom>
+          <a:noFill/>
+        </p:spPr>
+        <p:txBody>
+          <a:bodyPr wrap="none" lIns="0" rIns="0" tIns="0" bIns="0" anchor="t">
+            <a:spAutoFit/>
+          </a:bodyPr>
+          <a:lstStyle/>
+          <a:p>
+            <a:pPr>
+              <a:defRPr sz="1600" b="0">
                 <a:solidFill>
                   <a:srgbClr val="202124"/>
                 </a:solidFill>
@@ -9472,20 +9364,92 @@
               </a:defRPr>
             </a:pPr>
             <a:r>
-              <a:t>El ahorro proyectado exige calibrar la escala del modelo final.</a:t>
-            </a:r>
-          </a:p>
-        </p:txBody>
-      </p:sp>
-      <p:sp>
-        <p:nvSpPr>
-          <p:cNvPr id="15" name="TextBox 14"/>
-          <p:cNvSpPr txBox="1"/>
-          <p:nvPr/>
-        </p:nvSpPr>
-        <p:spPr>
-          <a:xfrm>
-            <a:off x="508000" y="4216400"/>
+              <a:t>Carreras por punto</a:t>
+            </a:r>
+          </a:p>
+        </p:txBody>
+      </p:sp>
+      <p:sp>
+        <p:nvSpPr>
+          <p:cNvPr id="16" name="TextBox 15"/>
+          <p:cNvSpPr txBox="1"/>
+          <p:nvPr/>
+        </p:nvSpPr>
+        <p:spPr>
+          <a:xfrm>
+            <a:off x="6223000" y="2741168"/>
+            <a:ext cx="2413000" cy="315468"/>
+          </a:xfrm>
+          <a:prstGeom prst="rect">
+            <a:avLst/>
+          </a:prstGeom>
+          <a:noFill/>
+        </p:spPr>
+        <p:txBody>
+          <a:bodyPr wrap="none" lIns="0" rIns="0" tIns="0" bIns="0" anchor="t">
+            <a:spAutoFit/>
+          </a:bodyPr>
+          <a:lstStyle/>
+          <a:p>
+            <a:pPr>
+              <a:defRPr sz="1600" b="0">
+                <a:solidFill>
+                  <a:srgbClr val="202124"/>
+                </a:solidFill>
+                <a:latin typeface="Arial"/>
+              </a:defRPr>
+            </a:pPr>
+            <a:r>
+              <a:t>de Stuff+ y lanzamiento</a:t>
+            </a:r>
+          </a:p>
+        </p:txBody>
+      </p:sp>
+      <p:sp>
+        <p:nvSpPr>
+          <p:cNvPr id="17" name="TextBox 16"/>
+          <p:cNvSpPr txBox="1"/>
+          <p:nvPr/>
+        </p:nvSpPr>
+        <p:spPr>
+          <a:xfrm>
+            <a:off x="508000" y="3683000"/>
+            <a:ext cx="8128000" cy="315468"/>
+          </a:xfrm>
+          <a:prstGeom prst="rect">
+            <a:avLst/>
+          </a:prstGeom>
+          <a:noFill/>
+        </p:spPr>
+        <p:txBody>
+          <a:bodyPr wrap="none" lIns="0" rIns="0" tIns="0" bIns="0" anchor="t">
+            <a:spAutoFit/>
+          </a:bodyPr>
+          <a:lstStyle/>
+          <a:p>
+            <a:pPr>
+              <a:defRPr sz="1600" b="1">
+                <a:solidFill>
+                  <a:srgbClr val="202124"/>
+                </a:solidFill>
+                <a:latin typeface="Arial"/>
+              </a:defRPr>
+            </a:pPr>
+            <a:r>
+              <a:t>Escala fuera de muestra. +10 puntos en todo el arsenal es un escenario.</a:t>
+            </a:r>
+          </a:p>
+        </p:txBody>
+      </p:sp>
+      <p:sp>
+        <p:nvSpPr>
+          <p:cNvPr id="18" name="TextBox 17"/>
+          <p:cNvSpPr txBox="1"/>
+          <p:nvPr/>
+        </p:nvSpPr>
+        <p:spPr>
+          <a:xfrm>
+            <a:off x="508000" y="4064000"/>
             <a:ext cx="8128000" cy="283972"/>
           </a:xfrm>
           <a:prstGeom prst="rect">
@@ -9508,7 +9472,7 @@
               </a:defRPr>
             </a:pPr>
             <a:r>
-              <a:t>Las tablas de conversión Stuff+ actuales describen escenarios.</a:t>
+              <a:t>El ahorro del staff está en la lámina anterior, por franquicia.</a:t>
             </a:r>
           </a:p>
         </p:txBody>

</xml_diff>